<commit_message>
Add radial 'How Splink Works' slide to the deck (all 3 formats)
New slide 2 in HTML/PPTX/PDF featuring the hub-and-spoke graphic; deck now 14
slides. HTML embeds the image inline (self-contained for media distribution).

Co-Authored-By: Claude Opus 4.8 (1M context) <noreply@anthropic.com>
</commit_message>
<xml_diff>
--- a/supporting/Legal-Exposure/slides/uk-data-linkage-tier1-exposure.pptx
+++ b/supporting/Legal-Exposure/slides/uk-data-linkage-tier1-exposure.pptx
@@ -18,6 +18,7 @@
     <p:sldId id="266" r:id="rId17"/>
     <p:sldId id="267" r:id="rId18"/>
     <p:sldId id="268" r:id="rId19"/>
+    <p:sldId id="269" r:id="rId20"/>
   </p:sldIdLst>
   <p:sldSz cx="12191695" cy="6858000" type="screen4x3"/>
   <p:notesSz cx="6858000" cy="9144000"/>
@@ -3293,7 +3294,7 @@
                 </a:solidFill>
                 <a:latin typeface="Consolas"/>
               </a:rPr>
-              <a:t>1 / 13</a:t>
+              <a:t>1 / 14</a:t>
             </a:r>
           </a:p>
         </p:txBody>
@@ -3353,7 +3354,7 @@
                 </a:solidFill>
                 <a:latin typeface="Consolas"/>
               </a:rPr>
-              <a:t>HANDLE WITH CARE</a:t>
+              <a:t>CLOSEST TO THE LINKAGE MACHINERY</a:t>
             </a:r>
           </a:p>
         </p:txBody>
@@ -3387,7 +3388,7 @@
                 </a:solidFill>
                 <a:latin typeface="Georgia"/>
               </a:rPr>
-              <a:t>Four items that look stronger than they are</a:t>
+              <a:t>The National Fraud Initiative — a Tier-2 warning</a:t>
             </a:r>
           </a:p>
         </p:txBody>
@@ -3420,12 +3421,21 @@
               </a:spcAft>
             </a:pPr>
             <a:r>
+              <a:rPr sz="1300" b="1">
+                <a:solidFill>
+                  <a:srgbClr val="F4B740"/>
+                </a:solidFill>
+                <a:latin typeface="Consolas"/>
+              </a:rPr>
+              <a:t>[ T2 ]  </a:t>
+            </a:r>
+            <a:r>
               <a:rPr sz="1450">
                 <a:solidFill>
                   <a:srgbClr val="E7EDF3"/>
                 </a:solidFill>
               </a:rPr>
-              <a:t>•  Royal Free–DeepMind (3 Jul 2017): ICO FOUND DPA 1998 non-compliance over ~1.6M records — but via a voluntary undertaking. No fine, no notice. Cite as 'finding via undertaking,' never a penalty.</a:t>
+              <a:t>Regulator concern, on the record — a consultation response, not enforcement.</a:t>
             </a:r>
           </a:p>
           <a:p>
@@ -3435,12 +3445,12 @@
               </a:spcAft>
             </a:pPr>
             <a:r>
-              <a:rPr sz="1450">
+              <a:rPr sz="1500">
                 <a:solidFill>
                   <a:srgbClr val="E7EDF3"/>
                 </a:solidFill>
               </a:rPr>
-              <a:t>•  Visa-streaming algorithm (2020): withdrawn before any hearing after the JCWI/Foxglove JR. Tier 2 — no ruling, no admission. 'Successful JR' is press shorthand.</a:t>
+              <a:t>On 26 March 2021 the ICO formally responded to the Cabinet Office's plan to expand the National Fraud Initiative's data-matching purposes. The most on-point item in the whole investigation.</a:t>
             </a:r>
           </a:p>
           <a:p>
@@ -3450,12 +3460,13 @@
               </a:spcAft>
             </a:pPr>
             <a:r>
-              <a:rPr sz="1450">
-                <a:solidFill>
-                  <a:srgbClr val="E7EDF3"/>
-                </a:solidFill>
-              </a:rPr>
-              <a:t>•  DWP Universal Credit [2020] EWCA Civ 778: real ruling against DWP — but irrationality over salary timing. Zero data-protection holding. Irrelevant.</a:t>
+              <a:rPr sz="1700" i="1">
+                <a:solidFill>
+                  <a:srgbClr val="FFFFFF"/>
+                </a:solidFill>
+                <a:latin typeface="Georgia"/>
+              </a:rPr>
+              <a:t>“…could potentially allow participants to conduct disproportionate searches for information about particular individuals across a wide range of sources without lawful cause.”</a:t>
             </a:r>
           </a:p>
           <a:p>
@@ -3465,12 +3476,28 @@
               </a:spcAft>
             </a:pPr>
             <a:r>
-              <a:rPr sz="1450">
+              <a:rPr sz="1500">
                 <a:solidFill>
                   <a:srgbClr val="E7EDF3"/>
                 </a:solidFill>
               </a:rPr>
-              <a:t>•  Home Office GPS tagging (1 Mar 2024): genuine ICO enforcement notice + warning — but DPIA/surveillance failure, NOT data-matching.</a:t>
+              <a:t>The ICO also warned the Cabinet Office 'has not yet undertaken a DPIA' and should do so before any processing. No Tier-1 enforcement or court ruling on inter-departmental data-matching was found.</a:t>
+            </a:r>
+          </a:p>
+          <a:p>
+            <a:pPr>
+              <a:spcAft>
+                <a:spcPts val="900"/>
+              </a:spcAft>
+            </a:pPr>
+            <a:r>
+              <a:rPr sz="1100">
+                <a:solidFill>
+                  <a:srgbClr val="9AA7B4"/>
+                </a:solidFill>
+                <a:latin typeface="Consolas"/>
+              </a:rPr>
+              <a:t>ICO consultation response on the NFI (26 Mar 2021), full PDF · related: ICO response on the Eligibility Verification Measure</a:t>
             </a:r>
           </a:p>
         </p:txBody>
@@ -3539,7 +3566,7 @@
                 </a:solidFill>
                 <a:latin typeface="Consolas"/>
               </a:rPr>
-              <a:t>10 / 13</a:t>
+              <a:t>10 / 14</a:t>
             </a:r>
           </a:p>
         </p:txBody>
@@ -3599,7 +3626,7 @@
                 </a:solidFill>
                 <a:latin typeface="Consolas"/>
               </a:rPr>
-              <a:t>HOW TO DEPLOY THIS HONESTLY</a:t>
+              <a:t>HANDLE WITH CARE</a:t>
             </a:r>
           </a:p>
         </p:txBody>
@@ -3633,7 +3660,7 @@
                 </a:solidFill>
                 <a:latin typeface="Georgia"/>
               </a:rPr>
-              <a:t>Positioning</a:t>
+              <a:t>Four items that look stronger than they are</a:t>
             </a:r>
           </a:p>
         </p:txBody>
@@ -3671,7 +3698,7 @@
                   <a:srgbClr val="E7EDF3"/>
                 </a:solidFill>
               </a:rPr>
-              <a:t>•  Lead with the adjacency, not a fabricated violation. The Tier-1 facts are next door, named and dated — the spine, not a claim that Data First was condemned.</a:t>
+              <a:t>•  Royal Free–DeepMind (3 Jul 2017): ICO FOUND DPA 1998 non-compliance over ~1.6M records — but via a voluntary undertaking. No fine, no notice. Cite as 'finding via undertaking,' never a penalty.</a:t>
             </a:r>
           </a:p>
           <a:p>
@@ -3686,7 +3713,7 @@
                   <a:srgbClr val="E7EDF3"/>
                 </a:solidFill>
               </a:rPr>
-              <a:t>•  The pattern is the argument. Three times the Home Office put safeguards in policy not law; three times the courts ruled that unlawful. The same posture runs through Data First / ONS IDS.</a:t>
+              <a:t>•  Visa-streaming algorithm (2020): withdrawn before any hearing after the JCWI/Foxglove JR. Tier 2 — no ruling, no admission. 'Successful JR' is press shorthand.</a:t>
             </a:r>
           </a:p>
           <a:p>
@@ -3701,7 +3728,7 @@
                   <a:srgbClr val="E7EDF3"/>
                 </a:solidFill>
               </a:rPr>
-              <a:t>•  Be precise on Royal Free and the visa tool. An opponent who catches 'fine' (it was an undertaking) or 'struck down' (it was a withdrawal) discredits the whole brief. Accuracy is the weapon.</a:t>
+              <a:t>•  DWP Universal Credit [2020] EWCA Civ 778: real ruling against DWP — but irrationality over salary timing. Zero data-protection holding. Irrelevant.</a:t>
             </a:r>
           </a:p>
           <a:p>
@@ -3716,7 +3743,7 @@
                   <a:srgbClr val="E7EDF3"/>
                 </a:solidFill>
               </a:rPr>
-              <a:t>•  State plainly the on-target verdict is 'none found.' That is a strength — the honest, searched result — and it pre-empts the 'you're exaggerating' rebuttal.</a:t>
+              <a:t>•  Home Office GPS tagging (1 Mar 2024): genuine ICO enforcement notice + warning — but DPIA/surveillance failure, NOT data-matching.</a:t>
             </a:r>
           </a:p>
         </p:txBody>
@@ -3785,7 +3812,7 @@
                 </a:solidFill>
                 <a:latin typeface="Consolas"/>
               </a:rPr>
-              <a:t>11 / 13</a:t>
+              <a:t>11 / 14</a:t>
             </a:r>
           </a:p>
         </p:txBody>
@@ -3845,7 +3872,7 @@
                 </a:solidFill>
                 <a:latin typeface="Consolas"/>
               </a:rPr>
-              <a:t>CAVEATS &amp; OPEN QUESTIONS</a:t>
+              <a:t>HOW TO DEPLOY THIS HONESTLY</a:t>
             </a:r>
           </a:p>
         </p:txBody>
@@ -3879,7 +3906,7 @@
                 </a:solidFill>
                 <a:latin typeface="Georgia"/>
               </a:rPr>
-              <a:t>What still needs nailing down</a:t>
+              <a:t>Positioning</a:t>
             </a:r>
           </a:p>
         </p:txBody>
@@ -3917,7 +3944,7 @@
                   <a:srgbClr val="E7EDF3"/>
                 </a:solidFill>
               </a:rPr>
-              <a:t>•  Whether the Cabinet Office ever completed the DPIA the ICO demanded in 2021, and whether the ICO followed up once expanded NFI matching went live.</a:t>
+              <a:t>•  Lead with the adjacency, not a fabricated violation. The Tier-1 facts are next door, named and dated — the spine, not a claim that Data First was condemned.</a:t>
             </a:r>
           </a:p>
           <a:p>
@@ -3932,7 +3959,7 @@
                   <a:srgbClr val="E7EDF3"/>
                 </a:solidFill>
               </a:rPr>
-              <a:t>•  Any Tier-1 action on the other big sharing regimes — DWP fraud matching, HMRC bulk sharing, Digital Economy Act 2017 powers — beyond the NFI consultation. Not yet searched to exhaustion.</a:t>
+              <a:t>•  The pattern is the argument. Three times the Home Office put safeguards in policy not law; three times the courts ruled that unlawful. The same posture runs through Data First / ONS IDS.</a:t>
             </a:r>
           </a:p>
           <a:p>
@@ -3947,7 +3974,7 @@
                   <a:srgbClr val="E7EDF3"/>
                 </a:solidFill>
               </a:rPr>
-              <a:t>•  The ICO enforcement register renders dynamically; the ONS 'none found' rests on converging searches, not a single authoritative query.</a:t>
+              <a:t>•  Be precise on Royal Free and the visa tool. An opponent who catches 'fine' (it was an undertaking) or 'struck down' (it was a withdrawal) discredits the whole brief. Accuracy is the weapon.</a:t>
             </a:r>
           </a:p>
           <a:p>
@@ -3962,7 +3989,7 @@
                   <a:srgbClr val="E7EDF3"/>
                 </a:solidFill>
               </a:rPr>
-              <a:t>•  An unreported or very recent filing against SI 2024/342 cannot be fully excluded.</a:t>
+              <a:t>•  State plainly the on-target verdict is 'none found.' That is a strength — the honest, searched result — and it pre-empts the 'you're exaggerating' rebuttal.</a:t>
             </a:r>
           </a:p>
         </p:txBody>
@@ -4031,7 +4058,7 @@
                 </a:solidFill>
                 <a:latin typeface="Consolas"/>
               </a:rPr>
-              <a:t>12 / 13</a:t>
+              <a:t>12 / 14</a:t>
             </a:r>
           </a:p>
         </p:txBody>
@@ -4091,7 +4118,7 @@
                 </a:solidFill>
                 <a:latin typeface="Consolas"/>
               </a:rPr>
-              <a:t>PRIMARY SOURCES · FULL SERIES</a:t>
+              <a:t>CAVEATS &amp; OPEN QUESTIONS</a:t>
             </a:r>
           </a:p>
         </p:txBody>
@@ -4125,7 +4152,7 @@
                 </a:solidFill>
                 <a:latin typeface="Georgia"/>
               </a:rPr>
-              <a:t>Citations</a:t>
+              <a:t>What still needs nailing down</a:t>
             </a:r>
           </a:p>
         </p:txBody>
@@ -4163,7 +4190,7 @@
                   <a:srgbClr val="E7EDF3"/>
                 </a:solidFill>
               </a:rPr>
-              <a:t>•  caselaw.nationalarchives.gov.uk / BAILII — [2023] EWHC 713 (Admin); [2020] EWCA Civ 778; [2021] EWCA Civ 800; [2023] EWCA Civ 1474</a:t>
+              <a:t>•  Whether the Cabinet Office ever completed the DPIA the ICO demanded in 2021, and whether the ICO followed up once expanded NFI matching went live.</a:t>
             </a:r>
           </a:p>
           <a:p>
@@ -4178,7 +4205,7 @@
                   <a:srgbClr val="E7EDF3"/>
                 </a:solidFill>
               </a:rPr>
-              <a:t>•  legislation.gov.uk — SI 2024/342 + Explanatory Memorandum; Data (Use and Access) Act 2025 (c.18)</a:t>
+              <a:t>•  Any Tier-1 action on the other big sharing regimes — DWP fraud matching, HMRC bulk sharing, Digital Economy Act 2017 powers — beyond the NFI consultation. Not yet searched to exhaustion.</a:t>
             </a:r>
           </a:p>
           <a:p>
@@ -4193,7 +4220,7 @@
                   <a:srgbClr val="E7EDF3"/>
                 </a:solidFill>
               </a:rPr>
-              <a:t>•  gov.uk — Data First / Splink ATR · DUAA summary  |  adruk.org governance  |  committees.parliament.uk/52403 (PAC 2026)</a:t>
+              <a:t>•  The ICO enforcement register renders dynamically; the ONS 'none found' rests on converging searches, not a single authoritative query.</a:t>
             </a:r>
           </a:p>
           <a:p>
@@ -4208,9 +4235,195 @@
                   <a:srgbClr val="E7EDF3"/>
                 </a:solidFill>
               </a:rPr>
-              <a:t>•  ico.org.uk — Royal Free; GPS tagging; immigration-exemption guide; National Fraud Initiative consultation (2021)  |  osr.statisticsauthority.gov.uk  |  foxglove.org.uk</a:t>
-            </a:r>
-          </a:p>
+              <a:t>•  An unreported or very recent filing against SI 2024/342 cannot be fully excluded.</a:t>
+            </a:r>
+          </a:p>
+        </p:txBody>
+      </p:sp>
+      <p:sp>
+        <p:nvSpPr>
+          <p:cNvPr id="5" name="TextBox 4"/>
+          <p:cNvSpPr txBox="1"/>
+          <p:nvPr/>
+        </p:nvSpPr>
+        <p:spPr>
+          <a:xfrm>
+            <a:off x="822960" y="6400800"/>
+            <a:ext cx="5486400" cy="365760"/>
+          </a:xfrm>
+          <a:prstGeom prst="rect">
+            <a:avLst/>
+          </a:prstGeom>
+          <a:noFill/>
+        </p:spPr>
+        <p:txBody>
+          <a:bodyPr wrap="square">
+            <a:spAutoFit/>
+          </a:bodyPr>
+          <a:lstStyle/>
+          <a:p>
+            <a:r>
+              <a:rPr sz="1000" b="1">
+                <a:solidFill>
+                  <a:srgbClr val="5AA9FF"/>
+                </a:solidFill>
+                <a:latin typeface="Consolas"/>
+              </a:rPr>
+              <a:t>brandonmyers.net</a:t>
+            </a:r>
+          </a:p>
+        </p:txBody>
+      </p:sp>
+      <p:sp>
+        <p:nvSpPr>
+          <p:cNvPr id="6" name="TextBox 5"/>
+          <p:cNvSpPr txBox="1"/>
+          <p:nvPr/>
+        </p:nvSpPr>
+        <p:spPr>
+          <a:xfrm>
+            <a:off x="9509760" y="6400800"/>
+            <a:ext cx="1828800" cy="365760"/>
+          </a:xfrm>
+          <a:prstGeom prst="rect">
+            <a:avLst/>
+          </a:prstGeom>
+          <a:noFill/>
+        </p:spPr>
+        <p:txBody>
+          <a:bodyPr wrap="square">
+            <a:spAutoFit/>
+          </a:bodyPr>
+          <a:lstStyle/>
+          <a:p>
+            <a:pPr algn="r"/>
+            <a:r>
+              <a:rPr sz="1000">
+                <a:solidFill>
+                  <a:srgbClr val="9AA7B4"/>
+                </a:solidFill>
+                <a:latin typeface="Consolas"/>
+              </a:rPr>
+              <a:t>13 / 14</a:t>
+            </a:r>
+          </a:p>
+        </p:txBody>
+      </p:sp>
+    </p:spTree>
+  </p:cSld>
+  <p:clrMapOvr>
+    <a:masterClrMapping/>
+  </p:clrMapOvr>
+</p:sld>
+</file>
+
+<file path=ppt/slides/slide14.xml><?xml version="1.0" encoding="utf-8"?>
+<p:sld xmlns:a="http://schemas.openxmlformats.org/drawingml/2006/main" xmlns:p="http://schemas.openxmlformats.org/presentationml/2006/main" xmlns:r="http://schemas.openxmlformats.org/officeDocument/2006/relationships">
+  <p:cSld>
+    <p:bg>
+      <p:bgPr>
+        <a:solidFill>
+          <a:srgbClr val="0E1116"/>
+        </a:solidFill>
+        <a:effectLst/>
+      </p:bgPr>
+    </p:bg>
+    <p:spTree>
+      <p:nvGrpSpPr>
+        <p:cNvPr id="1" name=""/>
+        <p:cNvGrpSpPr/>
+        <p:nvPr/>
+      </p:nvGrpSpPr>
+      <p:grpSpPr/>
+      <p:sp>
+        <p:nvSpPr>
+          <p:cNvPr id="2" name="TextBox 1"/>
+          <p:cNvSpPr txBox="1"/>
+          <p:nvPr/>
+        </p:nvSpPr>
+        <p:spPr>
+          <a:xfrm>
+            <a:off x="822960" y="457200"/>
+            <a:ext cx="10515600" cy="457200"/>
+          </a:xfrm>
+          <a:prstGeom prst="rect">
+            <a:avLst/>
+          </a:prstGeom>
+          <a:noFill/>
+        </p:spPr>
+        <p:txBody>
+          <a:bodyPr wrap="square">
+            <a:spAutoFit/>
+          </a:bodyPr>
+          <a:lstStyle/>
+          <a:p>
+            <a:r>
+              <a:rPr sz="1100" b="1">
+                <a:solidFill>
+                  <a:srgbClr val="5AA9FF"/>
+                </a:solidFill>
+                <a:latin typeface="Consolas"/>
+              </a:rPr>
+              <a:t>PRIMARY SOURCES · FULL SERIES</a:t>
+            </a:r>
+          </a:p>
+        </p:txBody>
+      </p:sp>
+      <p:sp>
+        <p:nvSpPr>
+          <p:cNvPr id="3" name="TextBox 2"/>
+          <p:cNvSpPr txBox="1"/>
+          <p:nvPr/>
+        </p:nvSpPr>
+        <p:spPr>
+          <a:xfrm>
+            <a:off x="822960" y="868680"/>
+            <a:ext cx="10515600" cy="1371600"/>
+          </a:xfrm>
+          <a:prstGeom prst="rect">
+            <a:avLst/>
+          </a:prstGeom>
+          <a:noFill/>
+        </p:spPr>
+        <p:txBody>
+          <a:bodyPr wrap="square">
+            <a:spAutoFit/>
+          </a:bodyPr>
+          <a:lstStyle/>
+          <a:p>
+            <a:r>
+              <a:rPr sz="3000" b="1">
+                <a:solidFill>
+                  <a:srgbClr val="FFFFFF"/>
+                </a:solidFill>
+                <a:latin typeface="Georgia"/>
+              </a:rPr>
+              <a:t>Citations</a:t>
+            </a:r>
+          </a:p>
+        </p:txBody>
+      </p:sp>
+      <p:sp>
+        <p:nvSpPr>
+          <p:cNvPr id="4" name="TextBox 3"/>
+          <p:cNvSpPr txBox="1"/>
+          <p:nvPr/>
+        </p:nvSpPr>
+        <p:spPr>
+          <a:xfrm>
+            <a:off x="822960" y="2240280"/>
+            <a:ext cx="10515600" cy="4023360"/>
+          </a:xfrm>
+          <a:prstGeom prst="rect">
+            <a:avLst/>
+          </a:prstGeom>
+          <a:noFill/>
+        </p:spPr>
+        <p:txBody>
+          <a:bodyPr wrap="square">
+            <a:spAutoFit/>
+          </a:bodyPr>
+          <a:lstStyle/>
           <a:p>
             <a:pPr>
               <a:spcAft>
@@ -4218,6 +4431,66 @@
               </a:spcAft>
             </a:pPr>
             <a:r>
+              <a:rPr sz="1450">
+                <a:solidFill>
+                  <a:srgbClr val="E7EDF3"/>
+                </a:solidFill>
+              </a:rPr>
+              <a:t>•  caselaw.nationalarchives.gov.uk / BAILII — [2023] EWHC 713 (Admin); [2020] EWCA Civ 778; [2021] EWCA Civ 800; [2023] EWCA Civ 1474</a:t>
+            </a:r>
+          </a:p>
+          <a:p>
+            <a:pPr>
+              <a:spcAft>
+                <a:spcPts val="900"/>
+              </a:spcAft>
+            </a:pPr>
+            <a:r>
+              <a:rPr sz="1450">
+                <a:solidFill>
+                  <a:srgbClr val="E7EDF3"/>
+                </a:solidFill>
+              </a:rPr>
+              <a:t>•  legislation.gov.uk — SI 2024/342 + Explanatory Memorandum; Data (Use and Access) Act 2025 (c.18)</a:t>
+            </a:r>
+          </a:p>
+          <a:p>
+            <a:pPr>
+              <a:spcAft>
+                <a:spcPts val="900"/>
+              </a:spcAft>
+            </a:pPr>
+            <a:r>
+              <a:rPr sz="1450">
+                <a:solidFill>
+                  <a:srgbClr val="E7EDF3"/>
+                </a:solidFill>
+              </a:rPr>
+              <a:t>•  gov.uk — Data First / Splink ATR · DUAA summary  |  adruk.org governance  |  committees.parliament.uk/52403 (PAC 2026)</a:t>
+            </a:r>
+          </a:p>
+          <a:p>
+            <a:pPr>
+              <a:spcAft>
+                <a:spcPts val="900"/>
+              </a:spcAft>
+            </a:pPr>
+            <a:r>
+              <a:rPr sz="1450">
+                <a:solidFill>
+                  <a:srgbClr val="E7EDF3"/>
+                </a:solidFill>
+              </a:rPr>
+              <a:t>•  ico.org.uk — Royal Free; GPS tagging; immigration-exemption guide; National Fraud Initiative consultation (2021)  |  osr.statisticsauthority.gov.uk  |  foxglove.org.uk</a:t>
+            </a:r>
+          </a:p>
+          <a:p>
+            <a:pPr>
+              <a:spcAft>
+                <a:spcPts val="900"/>
+              </a:spcAft>
+            </a:pPr>
+            <a:r>
               <a:rPr sz="1350">
                 <a:solidFill>
                   <a:srgbClr val="5AA9FF"/>
@@ -4292,7 +4565,7 @@
                 </a:solidFill>
                 <a:latin typeface="Consolas"/>
               </a:rPr>
-              <a:t>13 / 13</a:t>
+              <a:t>14 / 14</a:t>
             </a:r>
           </a:p>
         </p:txBody>
@@ -4352,7 +4625,7 @@
                 </a:solidFill>
                 <a:latin typeface="Consolas"/>
               </a:rPr>
-              <a:t>THE BOTTOM LINE</a:t>
+              <a:t>HOW THE MACHINE WORKS · THE PICTURE</a:t>
             </a:r>
           </a:p>
         </p:txBody>
@@ -4386,7 +4659,7 @@
                 </a:solidFill>
                 <a:latin typeface="Georgia"/>
               </a:rPr>
-              <a:t>No Tier-1 adjudication exists against any named target.</a:t>
+              <a:t>One person. Every dataset. No shared ID.</a:t>
             </a:r>
           </a:p>
         </p:txBody>
@@ -4412,41 +4685,70 @@
             <a:spAutoFit/>
           </a:bodyPr>
           <a:lstStyle/>
-          <a:p>
-            <a:pPr>
-              <a:spcAft>
-                <a:spcPts val="900"/>
-              </a:spcAft>
-            </a:pPr>
-            <a:r>
-              <a:rPr sz="1500">
-                <a:solidFill>
-                  <a:srgbClr val="E7EDF3"/>
-                </a:solidFill>
-              </a:rPr>
-              <a:t>Every genuine ruling of unlawfulness sits ADJACENT — in Home Office immigration data — not on the data-linkage systems themselves.</a:t>
-            </a:r>
-          </a:p>
-          <a:p>
-            <a:pPr>
-              <a:spcAft>
-                <a:spcPts val="900"/>
-              </a:spcAft>
-            </a:pPr>
-            <a:r>
-              <a:rPr sz="1350">
-                <a:solidFill>
-                  <a:srgbClr val="5AA9FF"/>
-                </a:solidFill>
-              </a:rPr>
-              <a:t>The honest, defensible frame: the same shortcut — keeping citizens' data-protection safeguards in policy instead of law — has been struck down by the courts three times. Not an asserted violation against Data First, which has never been adjudicated.</a:t>
-            </a:r>
-          </a:p>
-        </p:txBody>
-      </p:sp>
-      <p:sp>
-        <p:nvSpPr>
-          <p:cNvPr id="5" name="TextBox 4"/>
+          <a:p/>
+        </p:txBody>
+      </p:sp>
+      <p:pic>
+        <p:nvPicPr>
+          <p:cNvPr id="5" name="Picture 4" descr="splink-radial.png"/>
+          <p:cNvPicPr>
+            <a:picLocks noChangeAspect="1"/>
+          </p:cNvPicPr>
+          <p:nvPr/>
+        </p:nvPicPr>
+        <p:blipFill>
+          <a:blip r:embed="rId2"/>
+          <a:stretch>
+            <a:fillRect/>
+          </a:stretch>
+        </p:blipFill>
+        <p:spPr>
+          <a:xfrm>
+            <a:off x="4107027" y="1783080"/>
+            <a:ext cx="3977639" cy="3977639"/>
+          </a:xfrm>
+          <a:prstGeom prst="rect">
+            <a:avLst/>
+          </a:prstGeom>
+        </p:spPr>
+      </p:pic>
+      <p:sp>
+        <p:nvSpPr>
+          <p:cNvPr id="6" name="TextBox 5"/>
+          <p:cNvSpPr txBox="1"/>
+          <p:nvPr/>
+        </p:nvSpPr>
+        <p:spPr>
+          <a:xfrm>
+            <a:off x="1371600" y="5989320"/>
+            <a:ext cx="9448495" cy="640080"/>
+          </a:xfrm>
+          <a:prstGeom prst="rect">
+            <a:avLst/>
+          </a:prstGeom>
+          <a:noFill/>
+        </p:spPr>
+        <p:txBody>
+          <a:bodyPr wrap="square">
+            <a:spAutoFit/>
+          </a:bodyPr>
+          <a:lstStyle/>
+          <a:p>
+            <a:pPr algn="ctr"/>
+            <a:r>
+              <a:rPr sz="1100">
+                <a:solidFill>
+                  <a:srgbClr val="9AA7B4"/>
+                </a:solidFill>
+              </a:rPr>
+              <a:t>ONE PROFILE OF YOU at the centre; separate records splinter off across departments — Health, Tax, Courts, Police, Probation, Prisons, Benefits, Census, Immigration — matched by Splink (UK MoJ) with no shared ID, no consent, no opt-out.</a:t>
+            </a:r>
+          </a:p>
+        </p:txBody>
+      </p:sp>
+      <p:sp>
+        <p:nvSpPr>
+          <p:cNvPr id="7" name="TextBox 6"/>
           <p:cNvSpPr txBox="1"/>
           <p:nvPr/>
         </p:nvSpPr>
@@ -4480,7 +4782,7 @@
       </p:sp>
       <p:sp>
         <p:nvSpPr>
-          <p:cNvPr id="6" name="TextBox 5"/>
+          <p:cNvPr id="8" name="TextBox 7"/>
           <p:cNvSpPr txBox="1"/>
           <p:nvPr/>
         </p:nvSpPr>
@@ -4508,7 +4810,7 @@
                 </a:solidFill>
                 <a:latin typeface="Consolas"/>
               </a:rPr>
-              <a:t>2 / 13</a:t>
+              <a:t>2 / 14</a:t>
             </a:r>
           </a:p>
         </p:txBody>
@@ -4568,7 +4870,7 @@
                 </a:solidFill>
                 <a:latin typeface="Consolas"/>
               </a:rPr>
-              <a:t>HOW THIS WAS BUILT</a:t>
+              <a:t>THE BOTTOM LINE</a:t>
             </a:r>
           </a:p>
         </p:txBody>
@@ -4602,7 +4904,7 @@
                 </a:solidFill>
                 <a:latin typeface="Georgia"/>
               </a:rPr>
-              <a:t>Evidence standard</a:t>
+              <a:t>No Tier-1 adjudication exists against any named target.</a:t>
             </a:r>
           </a:p>
         </p:txBody>
@@ -4640,7 +4942,7 @@
                   <a:srgbClr val="E7EDF3"/>
                 </a:solidFill>
               </a:rPr>
-              <a:t>Three independent deep-research passes. Each claim extracted from fetched primary sources, then put through adversarial verification — a claim is killed unless it survives skeptical refutation. Tiering applied strictly; my own overreach killed too.</a:t>
+              <a:t>Every genuine ruling of unlawfulness sits ADJACENT — in Home Office immigration data — not on the data-linkage systems themselves.</a:t>
             </a:r>
           </a:p>
           <a:p>
@@ -4650,84 +4952,12 @@
               </a:spcAft>
             </a:pPr>
             <a:r>
-              <a:rPr sz="1500">
-                <a:solidFill>
-                  <a:srgbClr val="E7EDF3"/>
-                </a:solidFill>
-              </a:rPr>
-              <a:t>3 independent passes  ·  99 sources fetched  ·  ~300 verification agents  ·  4 claims killed for overreach</a:t>
-            </a:r>
-          </a:p>
-          <a:p>
-            <a:pPr>
-              <a:spcAft>
-                <a:spcPts val="900"/>
-              </a:spcAft>
-            </a:pPr>
-            <a:r>
-              <a:rPr sz="1300" b="1">
-                <a:solidFill>
-                  <a:srgbClr val="FF5D5D"/>
-                </a:solidFill>
-                <a:latin typeface="Consolas"/>
-              </a:rPr>
-              <a:t>[ T1 ]  </a:t>
-            </a:r>
-            <a:r>
-              <a:rPr sz="1450">
-                <a:solidFill>
-                  <a:srgbClr val="E7EDF3"/>
-                </a:solidFill>
-              </a:rPr>
-              <a:t>Enforcement notice / penalty / reprimand, or court ruling of unlawfulness</a:t>
-            </a:r>
-          </a:p>
-          <a:p>
-            <a:pPr>
-              <a:spcAft>
-                <a:spcPts val="900"/>
-              </a:spcAft>
-            </a:pPr>
-            <a:r>
-              <a:rPr sz="1300" b="1">
-                <a:solidFill>
-                  <a:srgbClr val="F4B740"/>
-                </a:solidFill>
-                <a:latin typeface="Consolas"/>
-              </a:rPr>
-              <a:t>[ T2 ]  </a:t>
-            </a:r>
-            <a:r>
-              <a:rPr sz="1450">
-                <a:solidFill>
-                  <a:srgbClr val="E7EDF3"/>
-                </a:solidFill>
-              </a:rPr>
-              <a:t>Regulator concern short of enforcement, or settled / withdrawn JR</a:t>
-            </a:r>
-          </a:p>
-          <a:p>
-            <a:pPr>
-              <a:spcAft>
-                <a:spcPts val="900"/>
-              </a:spcAft>
-            </a:pPr>
-            <a:r>
-              <a:rPr sz="1300" b="1">
-                <a:solidFill>
-                  <a:srgbClr val="8A93A0"/>
-                </a:solidFill>
-                <a:latin typeface="Consolas"/>
-              </a:rPr>
-              <a:t>[ T3 ]  </a:t>
-            </a:r>
-            <a:r>
-              <a:rPr sz="1450">
-                <a:solidFill>
-                  <a:srgbClr val="E7EDF3"/>
-                </a:solidFill>
-              </a:rPr>
-              <a:t>Criticism, no adjudication</a:t>
+              <a:rPr sz="1350">
+                <a:solidFill>
+                  <a:srgbClr val="5AA9FF"/>
+                </a:solidFill>
+              </a:rPr>
+              <a:t>The honest, defensible frame: the same shortcut — keeping citizens' data-protection safeguards in policy instead of law — has been struck down by the courts three times. Not an asserted violation against Data First, which has never been adjudicated.</a:t>
             </a:r>
           </a:p>
         </p:txBody>
@@ -4796,7 +5026,7 @@
                 </a:solidFill>
                 <a:latin typeface="Consolas"/>
               </a:rPr>
-              <a:t>3 / 13</a:t>
+              <a:t>3 / 14</a:t>
             </a:r>
           </a:p>
         </p:txBody>
@@ -4856,7 +5086,7 @@
                 </a:solidFill>
                 <a:latin typeface="Consolas"/>
               </a:rPr>
-              <a:t>PER-TARGET VERDICT</a:t>
+              <a:t>HOW THIS WAS BUILT</a:t>
             </a:r>
           </a:p>
         </p:txBody>
@@ -4890,7 +5120,7 @@
                 </a:solidFill>
                 <a:latin typeface="Georgia"/>
               </a:rPr>
-              <a:t>The four named systems</a:t>
+              <a:t>Evidence standard</a:t>
             </a:r>
           </a:p>
         </p:txBody>
@@ -4923,21 +5153,12 @@
               </a:spcAft>
             </a:pPr>
             <a:r>
-              <a:rPr sz="1300" b="1">
-                <a:solidFill>
-                  <a:srgbClr val="3FD07F"/>
-                </a:solidFill>
-                <a:latin typeface="Consolas"/>
-              </a:rPr>
-              <a:t>[ NONE ]  </a:t>
-            </a:r>
-            <a:r>
-              <a:rPr sz="1450">
+              <a:rPr sz="1500">
                 <a:solidFill>
                   <a:srgbClr val="E7EDF3"/>
                 </a:solidFill>
               </a:rPr>
-              <a:t>MoJ Data First — NONE. No legal challenge, ICO action, or court ruling. Only DPIA + Five Safes + panel oversight on record.</a:t>
+              <a:t>Three independent deep-research passes. Each claim extracted from fetched primary sources, then put through adversarial verification — a claim is killed unless it survives skeptical refutation. Tiering applied strictly; my own overreach killed too.</a:t>
             </a:r>
           </a:p>
           <a:p>
@@ -4947,21 +5168,12 @@
               </a:spcAft>
             </a:pPr>
             <a:r>
-              <a:rPr sz="1300" b="1">
-                <a:solidFill>
-                  <a:srgbClr val="3FD07F"/>
-                </a:solidFill>
-                <a:latin typeface="Consolas"/>
-              </a:rPr>
-              <a:t>[ NONE ]  </a:t>
-            </a:r>
-            <a:r>
-              <a:rPr sz="1450">
+              <a:rPr sz="1500">
                 <a:solidFill>
                   <a:srgbClr val="E7EDF3"/>
                 </a:solidFill>
               </a:rPr>
-              <a:t>Splink — NONE. The open-source record-linkage tool built for Data First; nothing adjudicated against it.</a:t>
+              <a:t>3 independent passes  ·  99 sources fetched  ·  ~300 verification agents  ·  4 claims killed for overreach</a:t>
             </a:r>
           </a:p>
           <a:p>
@@ -4973,11 +5185,11 @@
             <a:r>
               <a:rPr sz="1300" b="1">
                 <a:solidFill>
-                  <a:srgbClr val="3FD07F"/>
+                  <a:srgbClr val="FF5D5D"/>
                 </a:solidFill>
                 <a:latin typeface="Consolas"/>
               </a:rPr>
-              <a:t>[ NONE ]  </a:t>
+              <a:t>[ T1 ]  </a:t>
             </a:r>
             <a:r>
               <a:rPr sz="1450">
@@ -4985,7 +5197,7 @@
                   <a:srgbClr val="E7EDF3"/>
                 </a:solidFill>
               </a:rPr>
-              <a:t>ONS IDS / IDP — NONE, now searched directly, not inferred. Highest adverse material is Tier 3 only.</a:t>
+              <a:t>Enforcement notice / penalty / reprimand, or court ruling of unlawfulness</a:t>
             </a:r>
           </a:p>
           <a:p>
@@ -4997,11 +5209,11 @@
             <a:r>
               <a:rPr sz="1300" b="1">
                 <a:solidFill>
-                  <a:srgbClr val="3FD07F"/>
+                  <a:srgbClr val="F4B740"/>
                 </a:solidFill>
                 <a:latin typeface="Consolas"/>
               </a:rPr>
-              <a:t>[ NONE ]  </a:t>
+              <a:t>[ T2 ]  </a:t>
             </a:r>
             <a:r>
               <a:rPr sz="1450">
@@ -5009,7 +5221,7 @@
                   <a:srgbClr val="E7EDF3"/>
                 </a:solidFill>
               </a:rPr>
-              <a:t>ADR UK — NONE. Statutory safeguards; the ICO has endorsed the Five Safes model.</a:t>
+              <a:t>Regulator concern short of enforcement, or settled / withdrawn JR</a:t>
             </a:r>
           </a:p>
           <a:p>
@@ -5019,13 +5231,21 @@
               </a:spcAft>
             </a:pPr>
             <a:r>
-              <a:rPr sz="1100">
-                <a:solidFill>
-                  <a:srgbClr val="9AA7B4"/>
+              <a:rPr sz="1300" b="1">
+                <a:solidFill>
+                  <a:srgbClr val="8A93A0"/>
                 </a:solidFill>
                 <a:latin typeface="Consolas"/>
               </a:rPr>
-              <a:t>Sources: GOV.UK MoJ Data First/Splink ATR · ADR UK governance · OSR follow-up · PAC Mar 2026 · ICO enforcement register</a:t>
+              <a:t>[ T3 ]  </a:t>
+            </a:r>
+            <a:r>
+              <a:rPr sz="1450">
+                <a:solidFill>
+                  <a:srgbClr val="E7EDF3"/>
+                </a:solidFill>
+              </a:rPr>
+              <a:t>Criticism, no adjudication</a:t>
             </a:r>
           </a:p>
         </p:txBody>
@@ -5094,7 +5314,7 @@
                 </a:solidFill>
                 <a:latin typeface="Consolas"/>
               </a:rPr>
-              <a:t>4 / 13</a:t>
+              <a:t>4 / 14</a:t>
             </a:r>
           </a:p>
         </p:txBody>
@@ -5154,7 +5374,7 @@
                 </a:solidFill>
                 <a:latin typeface="Consolas"/>
               </a:rPr>
-              <a:t>GAP CLOSED · ONS IDS</a:t>
+              <a:t>PER-TARGET VERDICT</a:t>
             </a:r>
           </a:p>
         </p:txBody>
@@ -5188,7 +5408,7 @@
                 </a:solidFill>
                 <a:latin typeface="Georgia"/>
               </a:rPr>
-              <a:t>ONS IDS: searched directly — still nothing above Tier 3</a:t>
+              <a:t>The four named systems</a:t>
             </a:r>
           </a:p>
         </p:txBody>
@@ -5221,12 +5441,21 @@
               </a:spcAft>
             </a:pPr>
             <a:r>
-              <a:rPr sz="1500">
+              <a:rPr sz="1300" b="1">
+                <a:solidFill>
+                  <a:srgbClr val="3FD07F"/>
+                </a:solidFill>
+                <a:latin typeface="Consolas"/>
+              </a:rPr>
+              <a:t>[ NONE ]  </a:t>
+            </a:r>
+            <a:r>
+              <a:rPr sz="1450">
                 <a:solidFill>
                   <a:srgbClr val="E7EDF3"/>
                 </a:solidFill>
               </a:rPr>
-              <a:t>An earlier pass only inferred 'none' from absence. A dedicated sweep of the ICO register, NSDEC minutes, OSR reports and the March 2026 PAC report confirms it.</a:t>
+              <a:t>MoJ Data First — NONE. No legal challenge, ICO action, or court ruling. Only DPIA + Five Safes + panel oversight on record.</a:t>
             </a:r>
           </a:p>
           <a:p>
@@ -5238,11 +5467,11 @@
             <a:r>
               <a:rPr sz="1300" b="1">
                 <a:solidFill>
-                  <a:srgbClr val="8A93A0"/>
+                  <a:srgbClr val="3FD07F"/>
                 </a:solidFill>
                 <a:latin typeface="Consolas"/>
               </a:rPr>
-              <a:t>[ T3 ]  </a:t>
+              <a:t>[ NONE ]  </a:t>
             </a:r>
             <a:r>
               <a:rPr sz="1450">
@@ -5250,7 +5479,7 @@
                   <a:srgbClr val="E7EDF3"/>
                 </a:solidFill>
               </a:rPr>
-              <a:t>PAC 'Government use of data' (Mar 2026): criticism is value-for-money and adoption only. Zero references to ICO, GDPR, or unlawful processing.</a:t>
+              <a:t>Splink — NONE. The open-source record-linkage tool built for Data First; nothing adjudicated against it.</a:t>
             </a:r>
           </a:p>
           <a:p>
@@ -5262,11 +5491,11 @@
             <a:r>
               <a:rPr sz="1300" b="1">
                 <a:solidFill>
-                  <a:srgbClr val="8A93A0"/>
+                  <a:srgbClr val="3FD07F"/>
                 </a:solidFill>
                 <a:latin typeface="Consolas"/>
               </a:rPr>
-              <a:t>[ T3 ]  </a:t>
+              <a:t>[ NONE ]  </a:t>
             </a:r>
             <a:r>
               <a:rPr sz="1450">
@@ -5274,7 +5503,7 @@
                   <a:srgbClr val="E7EDF3"/>
                 </a:solidFill>
               </a:rPr>
-              <a:t>OSR (statistics regulator): engaged with IDS only at recommendation level. No enforcement power.</a:t>
+              <a:t>ONS IDS / IDP — NONE, now searched directly, not inferred. Highest adverse material is Tier 3 only.</a:t>
             </a:r>
           </a:p>
           <a:p>
@@ -5286,11 +5515,11 @@
             <a:r>
               <a:rPr sz="1300" b="1">
                 <a:solidFill>
-                  <a:srgbClr val="8A93A0"/>
+                  <a:srgbClr val="3FD07F"/>
                 </a:solidFill>
                 <a:latin typeface="Consolas"/>
               </a:rPr>
-              <a:t>[ T3 ]  </a:t>
+              <a:t>[ NONE ]  </a:t>
             </a:r>
             <a:r>
               <a:rPr sz="1450">
@@ -5298,7 +5527,7 @@
                   <a:srgbClr val="E7EDF3"/>
                 </a:solidFill>
               </a:rPr>
-              <a:t>NSDEC ethics committee: names IDS positively as a strategic project to prioritise for ethics review. Prospective assurance, not censure.</a:t>
+              <a:t>ADR UK — NONE. Statutory safeguards; the ICO has endorsed the Five Safes model.</a:t>
             </a:r>
           </a:p>
           <a:p>
@@ -5308,21 +5537,13 @@
               </a:spcAft>
             </a:pPr>
             <a:r>
-              <a:rPr sz="1300" b="1">
-                <a:solidFill>
-                  <a:srgbClr val="3FD07F"/>
+              <a:rPr sz="1100">
+                <a:solidFill>
+                  <a:srgbClr val="9AA7B4"/>
                 </a:solidFill>
                 <a:latin typeface="Consolas"/>
               </a:rPr>
-              <a:t>[ NONE ]  </a:t>
-            </a:r>
-            <a:r>
-              <a:rPr sz="1450">
-                <a:solidFill>
-                  <a:srgbClr val="E7EDF3"/>
-                </a:solidFill>
-              </a:rPr>
-              <a:t>ICO / Courts: no enforcement notice, penalty, reprimand, audit or opinion; no JR touching IDS/IDP linkage.</a:t>
+              <a:t>Sources: GOV.UK MoJ Data First/Splink ATR · ADR UK governance · OSR follow-up · PAC Mar 2026 · ICO enforcement register</a:t>
             </a:r>
           </a:p>
         </p:txBody>
@@ -5391,7 +5612,7 @@
                 </a:solidFill>
                 <a:latin typeface="Consolas"/>
               </a:rPr>
-              <a:t>5 / 13</a:t>
+              <a:t>5 / 14</a:t>
             </a:r>
           </a:p>
         </p:txBody>
@@ -5451,7 +5672,7 @@
                 </a:solidFill>
                 <a:latin typeface="Consolas"/>
               </a:rPr>
-              <a:t>ADJACENT TIER-1 · RULED UNLAWFUL THREE TIMES</a:t>
+              <a:t>GAP CLOSED · ONS IDS</a:t>
             </a:r>
           </a:p>
         </p:txBody>
@@ -5485,7 +5706,7 @@
                 </a:solidFill>
                 <a:latin typeface="Georgia"/>
               </a:rPr>
-              <a:t>The immigration exemption — 2021, 2023, 2023</a:t>
+              <a:t>ONS IDS: searched directly — still nothing above Tier 3</a:t>
             </a:r>
           </a:p>
         </p:txBody>
@@ -5518,12 +5739,12 @@
               </a:spcAft>
             </a:pPr>
             <a:r>
-              <a:rPr sz="1450">
+              <a:rPr sz="1500">
                 <a:solidFill>
                   <a:srgbClr val="E7EDF3"/>
                 </a:solidFill>
               </a:rPr>
-              <a:t>•  R1 · 26 May 2021 · Court of Appeal · [2021] EWCA Civ 800 — original exemption unlawful, an 'unauthorised derogation from the GDPR'.</a:t>
+              <a:t>An earlier pass only inferred 'none' from absence. A dedicated sweep of the ICO register, NSDEC minutes, OSR reports and the March 2026 PAC report confirms it.</a:t>
             </a:r>
           </a:p>
           <a:p>
@@ -5533,12 +5754,21 @@
               </a:spcAft>
             </a:pPr>
             <a:r>
+              <a:rPr sz="1300" b="1">
+                <a:solidFill>
+                  <a:srgbClr val="8A93A0"/>
+                </a:solidFill>
+                <a:latin typeface="Consolas"/>
+              </a:rPr>
+              <a:t>[ T3 ]  </a:t>
+            </a:r>
+            <a:r>
               <a:rPr sz="1450">
                 <a:solidFill>
                   <a:srgbClr val="E7EDF3"/>
                 </a:solidFill>
               </a:rPr>
-              <a:t>•  R2 · 29 Mar 2023 · High Court (Saini J) · [2023] EWHC 713 (Admin) — revised exemption STILL unlawful; safeguards can't live in policy.</a:t>
+              <a:t>PAC 'Government use of data' (Mar 2026): criticism is value-for-money and adoption only. Zero references to ICO, GDPR, or unlawful processing.</a:t>
             </a:r>
           </a:p>
           <a:p>
@@ -5548,12 +5778,21 @@
               </a:spcAft>
             </a:pPr>
             <a:r>
+              <a:rPr sz="1300" b="1">
+                <a:solidFill>
+                  <a:srgbClr val="8A93A0"/>
+                </a:solidFill>
+                <a:latin typeface="Consolas"/>
+              </a:rPr>
+              <a:t>[ T3 ]  </a:t>
+            </a:r>
+            <a:r>
               <a:rPr sz="1450">
                 <a:solidFill>
                   <a:srgbClr val="E7EDF3"/>
                 </a:solidFill>
               </a:rPr>
-              <a:t>•  R3 · 11 Dec 2023 · Court of Appeal · [2023] EWCA Civ 1474 — confirmed breach of Art 23(2). The ruling the 2024 fix answered.</a:t>
+              <a:t>OSR (statistics regulator): engaged with IDS only at recommendation level. No enforcement power.</a:t>
             </a:r>
           </a:p>
           <a:p>
@@ -5563,13 +5802,21 @@
               </a:spcAft>
             </a:pPr>
             <a:r>
-              <a:rPr sz="1700" i="1">
-                <a:solidFill>
-                  <a:srgbClr val="FFFFFF"/>
-                </a:solidFill>
-                <a:latin typeface="Georgia"/>
-              </a:rPr>
-              <a:t>“Safeguards must appear on the face of the legislation or in a binding code (approved by Parliament) and with statutory force.”</a:t>
+              <a:rPr sz="1300" b="1">
+                <a:solidFill>
+                  <a:srgbClr val="8A93A0"/>
+                </a:solidFill>
+                <a:latin typeface="Consolas"/>
+              </a:rPr>
+              <a:t>[ T3 ]  </a:t>
+            </a:r>
+            <a:r>
+              <a:rPr sz="1450">
+                <a:solidFill>
+                  <a:srgbClr val="E7EDF3"/>
+                </a:solidFill>
+              </a:rPr>
+              <a:t>NSDEC ethics committee: names IDS positively as a strategic project to prioritise for ethics review. Prospective assurance, not censure.</a:t>
             </a:r>
           </a:p>
           <a:p>
@@ -5579,13 +5826,21 @@
               </a:spcAft>
             </a:pPr>
             <a:r>
-              <a:rPr sz="1100">
-                <a:solidFill>
-                  <a:srgbClr val="9AA7B4"/>
+              <a:rPr sz="1300" b="1">
+                <a:solidFill>
+                  <a:srgbClr val="3FD07F"/>
                 </a:solidFill>
                 <a:latin typeface="Consolas"/>
               </a:rPr>
-              <a:t>BAILII / caselaw.nationalarchives.gov.uk [2023] EWHC 713 (Admin) · House of Lords Library · Open Rights Group</a:t>
+              <a:t>[ NONE ]  </a:t>
+            </a:r>
+            <a:r>
+              <a:rPr sz="1450">
+                <a:solidFill>
+                  <a:srgbClr val="E7EDF3"/>
+                </a:solidFill>
+              </a:rPr>
+              <a:t>ICO / Courts: no enforcement notice, penalty, reprimand, audit or opinion; no JR touching IDS/IDP linkage.</a:t>
             </a:r>
           </a:p>
         </p:txBody>
@@ -5654,7 +5909,7 @@
                 </a:solidFill>
                 <a:latin typeface="Consolas"/>
               </a:rPr>
-              <a:t>6 / 13</a:t>
+              <a:t>6 / 14</a:t>
             </a:r>
           </a:p>
         </p:txBody>
@@ -5714,7 +5969,7 @@
                 </a:solidFill>
                 <a:latin typeface="Consolas"/>
               </a:rPr>
-              <a:t>CURRENT STATUS · 2026</a:t>
+              <a:t>ADJACENT TIER-1 · RULED UNLAWFUL THREE TIMES</a:t>
             </a:r>
           </a:p>
         </p:txBody>
@@ -5748,7 +6003,7 @@
                 </a:solidFill>
                 <a:latin typeface="Georgia"/>
               </a:rPr>
-              <a:t>Struck down three times — then legislated back into force</a:t>
+              <a:t>The immigration exemption — 2021, 2023, 2023</a:t>
             </a:r>
           </a:p>
         </p:txBody>
@@ -5781,12 +6036,12 @@
               </a:spcAft>
             </a:pPr>
             <a:r>
-              <a:rPr sz="1500">
+              <a:rPr sz="1450">
                 <a:solidFill>
                   <a:srgbClr val="E7EDF3"/>
                 </a:solidFill>
               </a:rPr>
-              <a:t>The exemption was never struck down outright: each ruling used a suspended declaration, then the government re-legislated.</a:t>
+              <a:t>•  R1 · 26 May 2021 · Court of Appeal · [2021] EWCA Civ 800 — original exemption unlawful, an 'unauthorised derogation from the GDPR'.</a:t>
             </a:r>
           </a:p>
           <a:p>
@@ -5796,12 +6051,12 @@
               </a:spcAft>
             </a:pPr>
             <a:r>
-              <a:rPr sz="1350">
-                <a:solidFill>
-                  <a:srgbClr val="5AA9FF"/>
-                </a:solidFill>
-              </a:rPr>
-              <a:t>Operative text today: SI 2024/342 — Data Protection Act 2018 (Amendment of Schedule 2 Exemptions) Regulations 2024 — made 7 Mar 2024, in force 8 Mar 2024. It finally put case-by-case decision-making, a necessity/proportionality test, and vulnerability + Convention-rights safeguards on the face of the statute.</a:t>
+              <a:rPr sz="1450">
+                <a:solidFill>
+                  <a:srgbClr val="E7EDF3"/>
+                </a:solidFill>
+              </a:rPr>
+              <a:t>•  R2 · 29 Mar 2023 · High Court (Saini J) · [2023] EWHC 713 (Admin) — revised exemption STILL unlawful; safeguards can't live in policy.</a:t>
             </a:r>
           </a:p>
           <a:p>
@@ -5811,12 +6066,12 @@
               </a:spcAft>
             </a:pPr>
             <a:r>
-              <a:rPr sz="1350">
-                <a:solidFill>
-                  <a:srgbClr val="5AA9FF"/>
-                </a:solidFill>
-              </a:rPr>
-              <a:t>The successor statute, the Data (Use and Access) Act 2025 (Royal Assent 19 Jun 2025), left the immigration exemption untouched — it amends only the separate crime exemption. A dedicated search found no fourth round of litigation as of mid-2026.</a:t>
+              <a:rPr sz="1450">
+                <a:solidFill>
+                  <a:srgbClr val="E7EDF3"/>
+                </a:solidFill>
+              </a:rPr>
+              <a:t>•  R3 · 11 Dec 2023 · Court of Appeal · [2023] EWCA Civ 1474 — confirmed breach of Art 23(2). The ruling the 2024 fix answered.</a:t>
             </a:r>
           </a:p>
           <a:p>
@@ -5826,13 +6081,29 @@
               </a:spcAft>
             </a:pPr>
             <a:r>
+              <a:rPr sz="1700" i="1">
+                <a:solidFill>
+                  <a:srgbClr val="FFFFFF"/>
+                </a:solidFill>
+                <a:latin typeface="Georgia"/>
+              </a:rPr>
+              <a:t>“Safeguards must appear on the face of the legislation or in a binding code (approved by Parliament) and with statutory force.”</a:t>
+            </a:r>
+          </a:p>
+          <a:p>
+            <a:pPr>
+              <a:spcAft>
+                <a:spcPts val="900"/>
+              </a:spcAft>
+            </a:pPr>
+            <a:r>
               <a:rPr sz="1100">
                 <a:solidFill>
                   <a:srgbClr val="9AA7B4"/>
                 </a:solidFill>
                 <a:latin typeface="Consolas"/>
               </a:rPr>
-              <a:t>Confirmed verbatim: legislation.gov.uk SI 2024/342 + EM · Data (Use and Access) Act 2025 (c.18) · gov.uk DUAA summary</a:t>
+              <a:t>BAILII / caselaw.nationalarchives.gov.uk [2023] EWHC 713 (Admin) · House of Lords Library · Open Rights Group</a:t>
             </a:r>
           </a:p>
         </p:txBody>
@@ -5901,7 +6172,7 @@
                 </a:solidFill>
                 <a:latin typeface="Consolas"/>
               </a:rPr>
-              <a:t>7 / 13</a:t>
+              <a:t>7 / 14</a:t>
             </a:r>
           </a:p>
         </p:txBody>
@@ -5961,7 +6232,7 @@
                 </a:solidFill>
                 <a:latin typeface="Consolas"/>
               </a:rPr>
-              <a:t>THE DECISIVE POINT · READ BEFORE USING</a:t>
+              <a:t>CURRENT STATUS · 2026</a:t>
             </a:r>
           </a:p>
         </p:txBody>
@@ -5995,7 +6266,7 @@
                 </a:solidFill>
                 <a:latin typeface="Georgia"/>
               </a:rPr>
-              <a:t>Does the immigration ruling touch data-linkage?</a:t>
+              <a:t>Struck down three times — then legislated back into force</a:t>
             </a:r>
           </a:p>
         </p:txBody>
@@ -6033,7 +6304,7 @@
                   <a:srgbClr val="E7EDF3"/>
                 </a:solidFill>
               </a:rPr>
-              <a:t>Not directly. The unlawfulness is about an exemption from individuals' OWN data-subject rights — not about linking or sharing datasets. The defect was procedural: Art 23(2) safeguards must live in legislation, not policy. The judgments contain no discussion of inter-departmental sharing, record linkage, or bulk matching.</a:t>
+              <a:t>The exemption was never struck down outright: each ruling used a suspended declaration, then the government re-legislated.</a:t>
             </a:r>
           </a:p>
           <a:p>
@@ -6043,12 +6314,12 @@
               </a:spcAft>
             </a:pPr>
             <a:r>
-              <a:rPr sz="1450">
-                <a:solidFill>
-                  <a:srgbClr val="E7EDF3"/>
-                </a:solidFill>
-              </a:rPr>
-              <a:t>•  FAIR: the same department, the same trick of keeping safeguards out of the statute, ruled unlawful three times.</a:t>
+              <a:rPr sz="1350">
+                <a:solidFill>
+                  <a:srgbClr val="5AA9FF"/>
+                </a:solidFill>
+              </a:rPr>
+              <a:t>Operative text today: SI 2024/342 — Data Protection Act 2018 (Amendment of Schedule 2 Exemptions) Regulations 2024 — made 7 Mar 2024, in force 8 Mar 2024. It finally put case-by-case decision-making, a necessity/proportionality test, and vulnerability + Convention-rights safeguards on the face of the statute.</a:t>
             </a:r>
           </a:p>
           <a:p>
@@ -6058,12 +6329,12 @@
               </a:spcAft>
             </a:pPr>
             <a:r>
-              <a:rPr sz="1450">
-                <a:solidFill>
-                  <a:srgbClr val="E7EDF3"/>
-                </a:solidFill>
-              </a:rPr>
-              <a:t>•  OVERREACH (do not make this claim): that the courts have condemned government data-linkage. They have not.</a:t>
+              <a:rPr sz="1350">
+                <a:solidFill>
+                  <a:srgbClr val="5AA9FF"/>
+                </a:solidFill>
+              </a:rPr>
+              <a:t>The successor statute, the Data (Use and Access) Act 2025 (Royal Assent 19 Jun 2025), left the immigration exemption untouched — it amends only the separate crime exemption. A dedicated search found no fourth round of litigation as of mid-2026.</a:t>
             </a:r>
           </a:p>
           <a:p>
@@ -6079,7 +6350,7 @@
                 </a:solidFill>
                 <a:latin typeface="Consolas"/>
               </a:rPr>
-              <a:t>Basis: [2023] EWHC 713 (Admin) ratio · D. Erdos, UKCLA — 'focuses on data-subject rights, not inter-departmental data sharing or bulk matching.'</a:t>
+              <a:t>Confirmed verbatim: legislation.gov.uk SI 2024/342 + EM · Data (Use and Access) Act 2025 (c.18) · gov.uk DUAA summary</a:t>
             </a:r>
           </a:p>
         </p:txBody>
@@ -6148,7 +6419,7 @@
                 </a:solidFill>
                 <a:latin typeface="Consolas"/>
               </a:rPr>
-              <a:t>8 / 13</a:t>
+              <a:t>8 / 14</a:t>
             </a:r>
           </a:p>
         </p:txBody>
@@ -6208,7 +6479,7 @@
                 </a:solidFill>
                 <a:latin typeface="Consolas"/>
               </a:rPr>
-              <a:t>CLOSEST TO THE LINKAGE MACHINERY</a:t>
+              <a:t>THE DECISIVE POINT · READ BEFORE USING</a:t>
             </a:r>
           </a:p>
         </p:txBody>
@@ -6242,7 +6513,7 @@
                 </a:solidFill>
                 <a:latin typeface="Georgia"/>
               </a:rPr>
-              <a:t>The National Fraud Initiative — a Tier-2 warning</a:t>
+              <a:t>Does the immigration ruling touch data-linkage?</a:t>
             </a:r>
           </a:p>
         </p:txBody>
@@ -6275,21 +6546,12 @@
               </a:spcAft>
             </a:pPr>
             <a:r>
-              <a:rPr sz="1300" b="1">
-                <a:solidFill>
-                  <a:srgbClr val="F4B740"/>
-                </a:solidFill>
-                <a:latin typeface="Consolas"/>
-              </a:rPr>
-              <a:t>[ T2 ]  </a:t>
-            </a:r>
-            <a:r>
-              <a:rPr sz="1450">
+              <a:rPr sz="1500">
                 <a:solidFill>
                   <a:srgbClr val="E7EDF3"/>
                 </a:solidFill>
               </a:rPr>
-              <a:t>Regulator concern, on the record — a consultation response, not enforcement.</a:t>
+              <a:t>Not directly. The unlawfulness is about an exemption from individuals' OWN data-subject rights — not about linking or sharing datasets. The defect was procedural: Art 23(2) safeguards must live in legislation, not policy. The judgments contain no discussion of inter-departmental sharing, record linkage, or bulk matching.</a:t>
             </a:r>
           </a:p>
           <a:p>
@@ -6299,12 +6561,12 @@
               </a:spcAft>
             </a:pPr>
             <a:r>
-              <a:rPr sz="1500">
+              <a:rPr sz="1450">
                 <a:solidFill>
                   <a:srgbClr val="E7EDF3"/>
                 </a:solidFill>
               </a:rPr>
-              <a:t>On 26 March 2021 the ICO formally responded to the Cabinet Office's plan to expand the National Fraud Initiative's data-matching purposes. The most on-point item in the whole investigation.</a:t>
+              <a:t>•  FAIR: the same department, the same trick of keeping safeguards out of the statute, ruled unlawful three times.</a:t>
             </a:r>
           </a:p>
           <a:p>
@@ -6314,13 +6576,12 @@
               </a:spcAft>
             </a:pPr>
             <a:r>
-              <a:rPr sz="1700" i="1">
-                <a:solidFill>
-                  <a:srgbClr val="FFFFFF"/>
-                </a:solidFill>
-                <a:latin typeface="Georgia"/>
-              </a:rPr>
-              <a:t>“…could potentially allow participants to conduct disproportionate searches for information about particular individuals across a wide range of sources without lawful cause.”</a:t>
+              <a:rPr sz="1450">
+                <a:solidFill>
+                  <a:srgbClr val="E7EDF3"/>
+                </a:solidFill>
+              </a:rPr>
+              <a:t>•  OVERREACH (do not make this claim): that the courts have condemned government data-linkage. They have not.</a:t>
             </a:r>
           </a:p>
           <a:p>
@@ -6330,28 +6591,13 @@
               </a:spcAft>
             </a:pPr>
             <a:r>
-              <a:rPr sz="1500">
-                <a:solidFill>
-                  <a:srgbClr val="E7EDF3"/>
-                </a:solidFill>
-              </a:rPr>
-              <a:t>The ICO also warned the Cabinet Office 'has not yet undertaken a DPIA' and should do so before any processing. No Tier-1 enforcement or court ruling on inter-departmental data-matching was found.</a:t>
-            </a:r>
-          </a:p>
-          <a:p>
-            <a:pPr>
-              <a:spcAft>
-                <a:spcPts val="900"/>
-              </a:spcAft>
-            </a:pPr>
-            <a:r>
               <a:rPr sz="1100">
                 <a:solidFill>
                   <a:srgbClr val="9AA7B4"/>
                 </a:solidFill>
                 <a:latin typeface="Consolas"/>
               </a:rPr>
-              <a:t>ICO consultation response on the NFI (26 Mar 2021), full PDF · related: ICO response on the Eligibility Verification Measure</a:t>
+              <a:t>Basis: [2023] EWHC 713 (Admin) ratio · D. Erdos, UKCLA — 'focuses on data-subject rights, not inter-departmental data sharing or bulk matching.'</a:t>
             </a:r>
           </a:p>
         </p:txBody>
@@ -6420,7 +6666,7 @@
                 </a:solidFill>
                 <a:latin typeface="Consolas"/>
               </a:rPr>
-              <a:t>9 / 13</a:t>
+              <a:t>9 / 14</a:t>
             </a:r>
           </a:p>
         </p:txBody>

</xml_diff>